<commit_message>
Added AVL Tree Project page
</commit_message>
<xml_diff>
--- a/images/Logo.pptx
+++ b/images/Logo.pptx
@@ -9,6 +9,9 @@
     <p:sldId id="257" r:id="rId3"/>
     <p:sldId id="258" r:id="rId4"/>
     <p:sldId id="259" r:id="rId5"/>
+    <p:sldId id="260" r:id="rId6"/>
+    <p:sldId id="261" r:id="rId7"/>
+    <p:sldId id="262" r:id="rId8"/>
   </p:sldIdLst>
   <p:sldSz cx="12192000" cy="6858000"/>
   <p:notesSz cx="6858000" cy="9144000"/>
@@ -264,7 +267,7 @@
           <a:p>
             <a:fld id="{C7B30B39-B25F-9241-B1FA-1A9268F493D8}" type="datetimeFigureOut">
               <a:rPr lang="en-US" smtClean="0"/>
-              <a:t>11/25/19</a:t>
+              <a:t>12/7/19</a:t>
             </a:fld>
             <a:endParaRPr lang="en-US"/>
           </a:p>
@@ -464,7 +467,7 @@
           <a:p>
             <a:fld id="{C7B30B39-B25F-9241-B1FA-1A9268F493D8}" type="datetimeFigureOut">
               <a:rPr lang="en-US" smtClean="0"/>
-              <a:t>11/25/19</a:t>
+              <a:t>12/7/19</a:t>
             </a:fld>
             <a:endParaRPr lang="en-US"/>
           </a:p>
@@ -674,7 +677,7 @@
           <a:p>
             <a:fld id="{C7B30B39-B25F-9241-B1FA-1A9268F493D8}" type="datetimeFigureOut">
               <a:rPr lang="en-US" smtClean="0"/>
-              <a:t>11/25/19</a:t>
+              <a:t>12/7/19</a:t>
             </a:fld>
             <a:endParaRPr lang="en-US"/>
           </a:p>
@@ -874,7 +877,7 @@
           <a:p>
             <a:fld id="{C7B30B39-B25F-9241-B1FA-1A9268F493D8}" type="datetimeFigureOut">
               <a:rPr lang="en-US" smtClean="0"/>
-              <a:t>11/25/19</a:t>
+              <a:t>12/7/19</a:t>
             </a:fld>
             <a:endParaRPr lang="en-US"/>
           </a:p>
@@ -1150,7 +1153,7 @@
           <a:p>
             <a:fld id="{C7B30B39-B25F-9241-B1FA-1A9268F493D8}" type="datetimeFigureOut">
               <a:rPr lang="en-US" smtClean="0"/>
-              <a:t>11/25/19</a:t>
+              <a:t>12/7/19</a:t>
             </a:fld>
             <a:endParaRPr lang="en-US"/>
           </a:p>
@@ -1418,7 +1421,7 @@
           <a:p>
             <a:fld id="{C7B30B39-B25F-9241-B1FA-1A9268F493D8}" type="datetimeFigureOut">
               <a:rPr lang="en-US" smtClean="0"/>
-              <a:t>11/25/19</a:t>
+              <a:t>12/7/19</a:t>
             </a:fld>
             <a:endParaRPr lang="en-US"/>
           </a:p>
@@ -1833,7 +1836,7 @@
           <a:p>
             <a:fld id="{C7B30B39-B25F-9241-B1FA-1A9268F493D8}" type="datetimeFigureOut">
               <a:rPr lang="en-US" smtClean="0"/>
-              <a:t>11/25/19</a:t>
+              <a:t>12/7/19</a:t>
             </a:fld>
             <a:endParaRPr lang="en-US"/>
           </a:p>
@@ -1975,7 +1978,7 @@
           <a:p>
             <a:fld id="{C7B30B39-B25F-9241-B1FA-1A9268F493D8}" type="datetimeFigureOut">
               <a:rPr lang="en-US" smtClean="0"/>
-              <a:t>11/25/19</a:t>
+              <a:t>12/7/19</a:t>
             </a:fld>
             <a:endParaRPr lang="en-US"/>
           </a:p>
@@ -2088,7 +2091,7 @@
           <a:p>
             <a:fld id="{C7B30B39-B25F-9241-B1FA-1A9268F493D8}" type="datetimeFigureOut">
               <a:rPr lang="en-US" smtClean="0"/>
-              <a:t>11/25/19</a:t>
+              <a:t>12/7/19</a:t>
             </a:fld>
             <a:endParaRPr lang="en-US"/>
           </a:p>
@@ -2401,7 +2404,7 @@
           <a:p>
             <a:fld id="{C7B30B39-B25F-9241-B1FA-1A9268F493D8}" type="datetimeFigureOut">
               <a:rPr lang="en-US" smtClean="0"/>
-              <a:t>11/25/19</a:t>
+              <a:t>12/7/19</a:t>
             </a:fld>
             <a:endParaRPr lang="en-US"/>
           </a:p>
@@ -2690,7 +2693,7 @@
           <a:p>
             <a:fld id="{C7B30B39-B25F-9241-B1FA-1A9268F493D8}" type="datetimeFigureOut">
               <a:rPr lang="en-US" smtClean="0"/>
-              <a:t>11/25/19</a:t>
+              <a:t>12/7/19</a:t>
             </a:fld>
             <a:endParaRPr lang="en-US"/>
           </a:p>
@@ -2933,7 +2936,7 @@
           <a:p>
             <a:fld id="{C7B30B39-B25F-9241-B1FA-1A9268F493D8}" type="datetimeFigureOut">
               <a:rPr lang="en-US" smtClean="0"/>
-              <a:t>11/25/19</a:t>
+              <a:t>12/7/19</a:t>
             </a:fld>
             <a:endParaRPr lang="en-US"/>
           </a:p>
@@ -5207,6 +5210,1083 @@
 </p:sld>
 </file>
 
+<file path=ppt/slides/slide5.xml><?xml version="1.0" encoding="utf-8"?>
+<p:sld xmlns:a="http://schemas.openxmlformats.org/drawingml/2006/main" xmlns:r="http://schemas.openxmlformats.org/officeDocument/2006/relationships" xmlns:p="http://schemas.openxmlformats.org/presentationml/2006/main">
+  <p:cSld>
+    <p:spTree>
+      <p:nvGrpSpPr>
+        <p:cNvPr id="1" name=""/>
+        <p:cNvGrpSpPr/>
+        <p:nvPr/>
+      </p:nvGrpSpPr>
+      <p:grpSpPr>
+        <a:xfrm>
+          <a:off x="0" y="0"/>
+          <a:ext cx="0" cy="0"/>
+          <a:chOff x="0" y="0"/>
+          <a:chExt cx="0" cy="0"/>
+        </a:xfrm>
+      </p:grpSpPr>
+      <p:sp>
+        <p:nvSpPr>
+          <p:cNvPr id="6" name="Rectangle 5">
+            <a:extLst>
+              <a:ext uri="{FF2B5EF4-FFF2-40B4-BE49-F238E27FC236}">
+                <a16:creationId xmlns:a16="http://schemas.microsoft.com/office/drawing/2014/main" id="{F68F3E1A-564F-0945-A6DE-D9139DAF94D4}"/>
+              </a:ext>
+            </a:extLst>
+          </p:cNvPr>
+          <p:cNvSpPr/>
+          <p:nvPr/>
+        </p:nvSpPr>
+        <p:spPr>
+          <a:xfrm>
+            <a:off x="5965419" y="612828"/>
+            <a:ext cx="4996593" cy="4979208"/>
+          </a:xfrm>
+          <a:prstGeom prst="rect">
+            <a:avLst/>
+          </a:prstGeom>
+          <a:solidFill>
+            <a:srgbClr val="F6F7F8"/>
+          </a:solidFill>
+          <a:ln w="12700">
+            <a:solidFill>
+              <a:schemeClr val="bg2">
+                <a:lumMod val="75000"/>
+              </a:schemeClr>
+            </a:solidFill>
+          </a:ln>
+        </p:spPr>
+        <p:style>
+          <a:lnRef idx="2">
+            <a:schemeClr val="accent1">
+              <a:shade val="50000"/>
+            </a:schemeClr>
+          </a:lnRef>
+          <a:fillRef idx="1">
+            <a:schemeClr val="accent1"/>
+          </a:fillRef>
+          <a:effectRef idx="0">
+            <a:schemeClr val="accent1"/>
+          </a:effectRef>
+          <a:fontRef idx="minor">
+            <a:schemeClr val="lt1"/>
+          </a:fontRef>
+        </p:style>
+        <p:txBody>
+          <a:bodyPr rtlCol="0" anchor="ctr"/>
+          <a:lstStyle/>
+          <a:p>
+            <a:pPr algn="ctr"/>
+            <a:endParaRPr lang="en-US" dirty="0"/>
+          </a:p>
+        </p:txBody>
+      </p:sp>
+      <p:sp>
+        <p:nvSpPr>
+          <p:cNvPr id="15" name="Rectangle 14">
+            <a:extLst>
+              <a:ext uri="{FF2B5EF4-FFF2-40B4-BE49-F238E27FC236}">
+                <a16:creationId xmlns:a16="http://schemas.microsoft.com/office/drawing/2014/main" id="{BFC01515-0C75-A94E-A507-2C5D301A0614}"/>
+              </a:ext>
+            </a:extLst>
+          </p:cNvPr>
+          <p:cNvSpPr/>
+          <p:nvPr/>
+        </p:nvSpPr>
+        <p:spPr>
+          <a:xfrm>
+            <a:off x="5829296" y="503965"/>
+            <a:ext cx="5192486" cy="5178378"/>
+          </a:xfrm>
+          <a:prstGeom prst="rect">
+            <a:avLst/>
+          </a:prstGeom>
+          <a:noFill/>
+          <a:ln w="12700">
+            <a:noFill/>
+          </a:ln>
+        </p:spPr>
+        <p:style>
+          <a:lnRef idx="2">
+            <a:schemeClr val="accent1">
+              <a:shade val="50000"/>
+            </a:schemeClr>
+          </a:lnRef>
+          <a:fillRef idx="1">
+            <a:schemeClr val="accent1"/>
+          </a:fillRef>
+          <a:effectRef idx="0">
+            <a:schemeClr val="accent1"/>
+          </a:effectRef>
+          <a:fontRef idx="minor">
+            <a:schemeClr val="lt1"/>
+          </a:fontRef>
+        </p:style>
+        <p:txBody>
+          <a:bodyPr rtlCol="0" anchor="ctr"/>
+          <a:lstStyle/>
+          <a:p>
+            <a:pPr algn="ctr"/>
+            <a:endParaRPr lang="en-US" dirty="0"/>
+          </a:p>
+        </p:txBody>
+      </p:sp>
+      <p:sp>
+        <p:nvSpPr>
+          <p:cNvPr id="16" name="TextBox 15">
+            <a:extLst>
+              <a:ext uri="{FF2B5EF4-FFF2-40B4-BE49-F238E27FC236}">
+                <a16:creationId xmlns:a16="http://schemas.microsoft.com/office/drawing/2014/main" id="{A829F524-8735-6445-BDB9-D34750F6F8E1}"/>
+              </a:ext>
+            </a:extLst>
+          </p:cNvPr>
+          <p:cNvSpPr txBox="1"/>
+          <p:nvPr/>
+        </p:nvSpPr>
+        <p:spPr>
+          <a:xfrm>
+            <a:off x="8809496" y="4651176"/>
+            <a:ext cx="1412190" cy="584775"/>
+          </a:xfrm>
+          <a:prstGeom prst="rect">
+            <a:avLst/>
+          </a:prstGeom>
+          <a:noFill/>
+        </p:spPr>
+        <p:txBody>
+          <a:bodyPr wrap="square" rtlCol="0">
+            <a:spAutoFit/>
+          </a:bodyPr>
+          <a:lstStyle/>
+          <a:p>
+            <a:r>
+              <a:rPr lang="en-US" sz="3200" b="1" dirty="0">
+                <a:solidFill>
+                  <a:srgbClr val="335C7E"/>
+                </a:solidFill>
+                <a:latin typeface="Google Sans" panose="020B0503030502040204" pitchFamily="34" charset="0"/>
+              </a:rPr>
+              <a:t>BACK</a:t>
+            </a:r>
+            <a:r>
+              <a:rPr lang="en-US" sz="2400" b="1" dirty="0">
+                <a:solidFill>
+                  <a:srgbClr val="335C7E"/>
+                </a:solidFill>
+                <a:latin typeface="Google Sans Medium" panose="020B0503030502040204" pitchFamily="34" charset="0"/>
+              </a:rPr>
+              <a:t> </a:t>
+            </a:r>
+          </a:p>
+        </p:txBody>
+      </p:sp>
+      <p:sp>
+        <p:nvSpPr>
+          <p:cNvPr id="18" name="Rectangle 17">
+            <a:extLst>
+              <a:ext uri="{FF2B5EF4-FFF2-40B4-BE49-F238E27FC236}">
+                <a16:creationId xmlns:a16="http://schemas.microsoft.com/office/drawing/2014/main" id="{6D60967A-5C64-3F43-8D6D-A2B42DD03D0E}"/>
+              </a:ext>
+            </a:extLst>
+          </p:cNvPr>
+          <p:cNvSpPr/>
+          <p:nvPr/>
+        </p:nvSpPr>
+        <p:spPr>
+          <a:xfrm>
+            <a:off x="8809496" y="5495979"/>
+            <a:ext cx="2160000" cy="108000"/>
+          </a:xfrm>
+          <a:prstGeom prst="rect">
+            <a:avLst/>
+          </a:prstGeom>
+          <a:solidFill>
+            <a:srgbClr val="F59E9E"/>
+          </a:solidFill>
+          <a:ln w="12700">
+            <a:noFill/>
+          </a:ln>
+        </p:spPr>
+        <p:style>
+          <a:lnRef idx="2">
+            <a:schemeClr val="accent1">
+              <a:shade val="50000"/>
+            </a:schemeClr>
+          </a:lnRef>
+          <a:fillRef idx="1">
+            <a:schemeClr val="accent1"/>
+          </a:fillRef>
+          <a:effectRef idx="0">
+            <a:schemeClr val="accent1"/>
+          </a:effectRef>
+          <a:fontRef idx="minor">
+            <a:schemeClr val="lt1"/>
+          </a:fontRef>
+        </p:style>
+        <p:txBody>
+          <a:bodyPr rtlCol="0" anchor="ctr"/>
+          <a:lstStyle/>
+          <a:p>
+            <a:pPr algn="ctr"/>
+            <a:endParaRPr lang="en-US"/>
+          </a:p>
+        </p:txBody>
+      </p:sp>
+      <p:sp>
+        <p:nvSpPr>
+          <p:cNvPr id="19" name="Rectangle 18">
+            <a:extLst>
+              <a:ext uri="{FF2B5EF4-FFF2-40B4-BE49-F238E27FC236}">
+                <a16:creationId xmlns:a16="http://schemas.microsoft.com/office/drawing/2014/main" id="{E6E91D9A-3F17-CD48-80AF-BE2201A25D59}"/>
+              </a:ext>
+            </a:extLst>
+          </p:cNvPr>
+          <p:cNvSpPr/>
+          <p:nvPr/>
+        </p:nvSpPr>
+        <p:spPr>
+          <a:xfrm>
+            <a:off x="10883897" y="612828"/>
+            <a:ext cx="108000" cy="2160000"/>
+          </a:xfrm>
+          <a:prstGeom prst="rect">
+            <a:avLst/>
+          </a:prstGeom>
+          <a:solidFill>
+            <a:srgbClr val="F1727F"/>
+          </a:solidFill>
+          <a:ln w="12700">
+            <a:noFill/>
+          </a:ln>
+        </p:spPr>
+        <p:style>
+          <a:lnRef idx="2">
+            <a:schemeClr val="accent1">
+              <a:shade val="50000"/>
+            </a:schemeClr>
+          </a:lnRef>
+          <a:fillRef idx="1">
+            <a:schemeClr val="accent1"/>
+          </a:fillRef>
+          <a:effectRef idx="0">
+            <a:schemeClr val="accent1"/>
+          </a:effectRef>
+          <a:fontRef idx="minor">
+            <a:schemeClr val="lt1"/>
+          </a:fontRef>
+        </p:style>
+        <p:txBody>
+          <a:bodyPr rtlCol="0" anchor="ctr"/>
+          <a:lstStyle/>
+          <a:p>
+            <a:pPr algn="ctr"/>
+            <a:endParaRPr lang="en-US"/>
+          </a:p>
+        </p:txBody>
+      </p:sp>
+      <p:sp>
+        <p:nvSpPr>
+          <p:cNvPr id="20" name="Rectangle 19">
+            <a:extLst>
+              <a:ext uri="{FF2B5EF4-FFF2-40B4-BE49-F238E27FC236}">
+                <a16:creationId xmlns:a16="http://schemas.microsoft.com/office/drawing/2014/main" id="{7E7A09BF-47D5-7249-8FDD-25D8B773A542}"/>
+              </a:ext>
+            </a:extLst>
+          </p:cNvPr>
+          <p:cNvSpPr/>
+          <p:nvPr/>
+        </p:nvSpPr>
+        <p:spPr>
+          <a:xfrm>
+            <a:off x="5965395" y="612828"/>
+            <a:ext cx="2160000" cy="108000"/>
+          </a:xfrm>
+          <a:prstGeom prst="rect">
+            <a:avLst/>
+          </a:prstGeom>
+          <a:solidFill>
+            <a:srgbClr val="C16C86"/>
+          </a:solidFill>
+          <a:ln w="12700">
+            <a:noFill/>
+          </a:ln>
+        </p:spPr>
+        <p:style>
+          <a:lnRef idx="2">
+            <a:schemeClr val="accent1">
+              <a:shade val="50000"/>
+            </a:schemeClr>
+          </a:lnRef>
+          <a:fillRef idx="1">
+            <a:schemeClr val="accent1"/>
+          </a:fillRef>
+          <a:effectRef idx="0">
+            <a:schemeClr val="accent1"/>
+          </a:effectRef>
+          <a:fontRef idx="minor">
+            <a:schemeClr val="lt1"/>
+          </a:fontRef>
+        </p:style>
+        <p:txBody>
+          <a:bodyPr rtlCol="0" anchor="ctr"/>
+          <a:lstStyle/>
+          <a:p>
+            <a:pPr algn="ctr"/>
+            <a:endParaRPr lang="en-US"/>
+          </a:p>
+        </p:txBody>
+      </p:sp>
+      <p:sp>
+        <p:nvSpPr>
+          <p:cNvPr id="21" name="Rectangle 20">
+            <a:extLst>
+              <a:ext uri="{FF2B5EF4-FFF2-40B4-BE49-F238E27FC236}">
+                <a16:creationId xmlns:a16="http://schemas.microsoft.com/office/drawing/2014/main" id="{8AF850E0-8C52-7B4C-A384-A31B2EAC3111}"/>
+              </a:ext>
+            </a:extLst>
+          </p:cNvPr>
+          <p:cNvSpPr/>
+          <p:nvPr/>
+        </p:nvSpPr>
+        <p:spPr>
+          <a:xfrm>
+            <a:off x="5965395" y="3432036"/>
+            <a:ext cx="108000" cy="2160000"/>
+          </a:xfrm>
+          <a:prstGeom prst="rect">
+            <a:avLst/>
+          </a:prstGeom>
+          <a:solidFill>
+            <a:srgbClr val="335C7E"/>
+          </a:solidFill>
+          <a:ln w="12700">
+            <a:noFill/>
+          </a:ln>
+        </p:spPr>
+        <p:style>
+          <a:lnRef idx="2">
+            <a:schemeClr val="accent1">
+              <a:shade val="50000"/>
+            </a:schemeClr>
+          </a:lnRef>
+          <a:fillRef idx="1">
+            <a:schemeClr val="accent1"/>
+          </a:fillRef>
+          <a:effectRef idx="0">
+            <a:schemeClr val="accent1"/>
+          </a:effectRef>
+          <a:fontRef idx="minor">
+            <a:schemeClr val="lt1"/>
+          </a:fontRef>
+        </p:style>
+        <p:txBody>
+          <a:bodyPr rtlCol="0" anchor="ctr"/>
+          <a:lstStyle/>
+          <a:p>
+            <a:pPr algn="ctr"/>
+            <a:endParaRPr lang="en-US"/>
+          </a:p>
+        </p:txBody>
+      </p:sp>
+      <p:sp>
+        <p:nvSpPr>
+          <p:cNvPr id="3" name="L-shape 2">
+            <a:extLst>
+              <a:ext uri="{FF2B5EF4-FFF2-40B4-BE49-F238E27FC236}">
+                <a16:creationId xmlns:a16="http://schemas.microsoft.com/office/drawing/2014/main" id="{9DAFBCD1-02A0-C243-AD90-AE00844EA27C}"/>
+              </a:ext>
+            </a:extLst>
+          </p:cNvPr>
+          <p:cNvSpPr/>
+          <p:nvPr/>
+        </p:nvSpPr>
+        <p:spPr>
+          <a:xfrm rot="2652370">
+            <a:off x="7264995" y="2242032"/>
+            <a:ext cx="1720800" cy="1720800"/>
+          </a:xfrm>
+          <a:prstGeom prst="corner">
+            <a:avLst>
+              <a:gd name="adj1" fmla="val 28205"/>
+              <a:gd name="adj2" fmla="val 27564"/>
+            </a:avLst>
+          </a:prstGeom>
+          <a:solidFill>
+            <a:srgbClr val="335C7E"/>
+          </a:solidFill>
+          <a:ln>
+            <a:noFill/>
+          </a:ln>
+        </p:spPr>
+        <p:style>
+          <a:lnRef idx="2">
+            <a:schemeClr val="accent1">
+              <a:shade val="50000"/>
+            </a:schemeClr>
+          </a:lnRef>
+          <a:fillRef idx="1">
+            <a:schemeClr val="accent1"/>
+          </a:fillRef>
+          <a:effectRef idx="0">
+            <a:schemeClr val="accent1"/>
+          </a:effectRef>
+          <a:fontRef idx="minor">
+            <a:schemeClr val="lt1"/>
+          </a:fontRef>
+        </p:style>
+        <p:txBody>
+          <a:bodyPr rtlCol="0" anchor="ctr"/>
+          <a:lstStyle/>
+          <a:p>
+            <a:pPr algn="ctr"/>
+            <a:endParaRPr lang="en-US"/>
+          </a:p>
+        </p:txBody>
+      </p:sp>
+      <p:sp>
+        <p:nvSpPr>
+          <p:cNvPr id="7" name="Rectangle 6">
+            <a:extLst>
+              <a:ext uri="{FF2B5EF4-FFF2-40B4-BE49-F238E27FC236}">
+                <a16:creationId xmlns:a16="http://schemas.microsoft.com/office/drawing/2014/main" id="{3F22B226-3D3D-0C4D-A38D-EAFD59989359}"/>
+              </a:ext>
+            </a:extLst>
+          </p:cNvPr>
+          <p:cNvSpPr/>
+          <p:nvPr/>
+        </p:nvSpPr>
+        <p:spPr>
+          <a:xfrm>
+            <a:off x="7409009" y="2825903"/>
+            <a:ext cx="2069182" cy="553057"/>
+          </a:xfrm>
+          <a:prstGeom prst="rect">
+            <a:avLst/>
+          </a:prstGeom>
+          <a:solidFill>
+            <a:srgbClr val="335C7E"/>
+          </a:solidFill>
+          <a:ln>
+            <a:noFill/>
+          </a:ln>
+        </p:spPr>
+        <p:style>
+          <a:lnRef idx="2">
+            <a:schemeClr val="accent1">
+              <a:shade val="50000"/>
+            </a:schemeClr>
+          </a:lnRef>
+          <a:fillRef idx="1">
+            <a:schemeClr val="accent1"/>
+          </a:fillRef>
+          <a:effectRef idx="0">
+            <a:schemeClr val="accent1"/>
+          </a:effectRef>
+          <a:fontRef idx="minor">
+            <a:schemeClr val="lt1"/>
+          </a:fontRef>
+        </p:style>
+        <p:txBody>
+          <a:bodyPr rtlCol="0" anchor="ctr"/>
+          <a:lstStyle/>
+          <a:p>
+            <a:pPr algn="ctr"/>
+            <a:endParaRPr lang="en-US"/>
+          </a:p>
+        </p:txBody>
+      </p:sp>
+    </p:spTree>
+    <p:extLst>
+      <p:ext uri="{BB962C8B-B14F-4D97-AF65-F5344CB8AC3E}">
+        <p14:creationId xmlns:p14="http://schemas.microsoft.com/office/powerpoint/2010/main" val="1818785394"/>
+      </p:ext>
+    </p:extLst>
+  </p:cSld>
+  <p:clrMapOvr>
+    <a:masterClrMapping/>
+  </p:clrMapOvr>
+</p:sld>
+</file>
+
+<file path=ppt/slides/slide6.xml><?xml version="1.0" encoding="utf-8"?>
+<p:sld xmlns:a="http://schemas.openxmlformats.org/drawingml/2006/main" xmlns:r="http://schemas.openxmlformats.org/officeDocument/2006/relationships" xmlns:p="http://schemas.openxmlformats.org/presentationml/2006/main">
+  <p:cSld>
+    <p:spTree>
+      <p:nvGrpSpPr>
+        <p:cNvPr id="1" name=""/>
+        <p:cNvGrpSpPr/>
+        <p:nvPr/>
+      </p:nvGrpSpPr>
+      <p:grpSpPr>
+        <a:xfrm>
+          <a:off x="0" y="0"/>
+          <a:ext cx="0" cy="0"/>
+          <a:chOff x="0" y="0"/>
+          <a:chExt cx="0" cy="0"/>
+        </a:xfrm>
+      </p:grpSpPr>
+      <p:sp>
+        <p:nvSpPr>
+          <p:cNvPr id="6" name="Rectangle 5">
+            <a:extLst>
+              <a:ext uri="{FF2B5EF4-FFF2-40B4-BE49-F238E27FC236}">
+                <a16:creationId xmlns:a16="http://schemas.microsoft.com/office/drawing/2014/main" id="{F68F3E1A-564F-0945-A6DE-D9139DAF94D4}"/>
+              </a:ext>
+            </a:extLst>
+          </p:cNvPr>
+          <p:cNvSpPr/>
+          <p:nvPr/>
+        </p:nvSpPr>
+        <p:spPr>
+          <a:xfrm>
+            <a:off x="7064877" y="612828"/>
+            <a:ext cx="4996593" cy="4979208"/>
+          </a:xfrm>
+          <a:prstGeom prst="rect">
+            <a:avLst/>
+          </a:prstGeom>
+          <a:solidFill>
+            <a:srgbClr val="F6F7F8"/>
+          </a:solidFill>
+          <a:ln w="12700">
+            <a:noFill/>
+          </a:ln>
+        </p:spPr>
+        <p:style>
+          <a:lnRef idx="2">
+            <a:schemeClr val="accent1">
+              <a:shade val="50000"/>
+            </a:schemeClr>
+          </a:lnRef>
+          <a:fillRef idx="1">
+            <a:schemeClr val="accent1"/>
+          </a:fillRef>
+          <a:effectRef idx="0">
+            <a:schemeClr val="accent1"/>
+          </a:effectRef>
+          <a:fontRef idx="minor">
+            <a:schemeClr val="lt1"/>
+          </a:fontRef>
+        </p:style>
+        <p:txBody>
+          <a:bodyPr rtlCol="0" anchor="ctr"/>
+          <a:lstStyle/>
+          <a:p>
+            <a:pPr algn="ctr"/>
+            <a:endParaRPr lang="en-US" dirty="0"/>
+          </a:p>
+        </p:txBody>
+      </p:sp>
+      <p:sp>
+        <p:nvSpPr>
+          <p:cNvPr id="15" name="Rectangle 14">
+            <a:extLst>
+              <a:ext uri="{FF2B5EF4-FFF2-40B4-BE49-F238E27FC236}">
+                <a16:creationId xmlns:a16="http://schemas.microsoft.com/office/drawing/2014/main" id="{BFC01515-0C75-A94E-A507-2C5D301A0614}"/>
+              </a:ext>
+            </a:extLst>
+          </p:cNvPr>
+          <p:cNvSpPr/>
+          <p:nvPr/>
+        </p:nvSpPr>
+        <p:spPr>
+          <a:xfrm>
+            <a:off x="6928754" y="503965"/>
+            <a:ext cx="5192486" cy="5178378"/>
+          </a:xfrm>
+          <a:prstGeom prst="rect">
+            <a:avLst/>
+          </a:prstGeom>
+          <a:noFill/>
+          <a:ln w="12700">
+            <a:noFill/>
+          </a:ln>
+        </p:spPr>
+        <p:style>
+          <a:lnRef idx="2">
+            <a:schemeClr val="accent1">
+              <a:shade val="50000"/>
+            </a:schemeClr>
+          </a:lnRef>
+          <a:fillRef idx="1">
+            <a:schemeClr val="accent1"/>
+          </a:fillRef>
+          <a:effectRef idx="0">
+            <a:schemeClr val="accent1"/>
+          </a:effectRef>
+          <a:fontRef idx="minor">
+            <a:schemeClr val="lt1"/>
+          </a:fontRef>
+        </p:style>
+        <p:txBody>
+          <a:bodyPr rtlCol="0" anchor="ctr"/>
+          <a:lstStyle/>
+          <a:p>
+            <a:pPr algn="ctr"/>
+            <a:endParaRPr lang="en-US" dirty="0"/>
+          </a:p>
+        </p:txBody>
+      </p:sp>
+      <p:sp>
+        <p:nvSpPr>
+          <p:cNvPr id="16" name="TextBox 15">
+            <a:extLst>
+              <a:ext uri="{FF2B5EF4-FFF2-40B4-BE49-F238E27FC236}">
+                <a16:creationId xmlns:a16="http://schemas.microsoft.com/office/drawing/2014/main" id="{A829F524-8735-6445-BDB9-D34750F6F8E1}"/>
+              </a:ext>
+            </a:extLst>
+          </p:cNvPr>
+          <p:cNvSpPr txBox="1"/>
+          <p:nvPr/>
+        </p:nvSpPr>
+        <p:spPr>
+          <a:xfrm>
+            <a:off x="9908954" y="4651176"/>
+            <a:ext cx="1412190" cy="584775"/>
+          </a:xfrm>
+          <a:prstGeom prst="rect">
+            <a:avLst/>
+          </a:prstGeom>
+          <a:noFill/>
+        </p:spPr>
+        <p:txBody>
+          <a:bodyPr wrap="square" rtlCol="0">
+            <a:spAutoFit/>
+          </a:bodyPr>
+          <a:lstStyle/>
+          <a:p>
+            <a:r>
+              <a:rPr lang="en-US" sz="3200" b="1" dirty="0">
+                <a:solidFill>
+                  <a:srgbClr val="335C7E"/>
+                </a:solidFill>
+                <a:latin typeface="Google Sans" panose="020B0503030502040204" pitchFamily="34" charset="0"/>
+              </a:rPr>
+              <a:t>BACK</a:t>
+            </a:r>
+            <a:r>
+              <a:rPr lang="en-US" sz="2400" b="1" dirty="0">
+                <a:solidFill>
+                  <a:srgbClr val="335C7E"/>
+                </a:solidFill>
+                <a:latin typeface="Google Sans Medium" panose="020B0503030502040204" pitchFamily="34" charset="0"/>
+              </a:rPr>
+              <a:t> </a:t>
+            </a:r>
+          </a:p>
+        </p:txBody>
+      </p:sp>
+      <p:sp>
+        <p:nvSpPr>
+          <p:cNvPr id="3" name="L-shape 2">
+            <a:extLst>
+              <a:ext uri="{FF2B5EF4-FFF2-40B4-BE49-F238E27FC236}">
+                <a16:creationId xmlns:a16="http://schemas.microsoft.com/office/drawing/2014/main" id="{9DAFBCD1-02A0-C243-AD90-AE00844EA27C}"/>
+              </a:ext>
+            </a:extLst>
+          </p:cNvPr>
+          <p:cNvSpPr/>
+          <p:nvPr/>
+        </p:nvSpPr>
+        <p:spPr>
+          <a:xfrm rot="2652370">
+            <a:off x="8364453" y="2242032"/>
+            <a:ext cx="1720800" cy="1720800"/>
+          </a:xfrm>
+          <a:prstGeom prst="corner">
+            <a:avLst>
+              <a:gd name="adj1" fmla="val 28205"/>
+              <a:gd name="adj2" fmla="val 27564"/>
+            </a:avLst>
+          </a:prstGeom>
+          <a:solidFill>
+            <a:srgbClr val="335C7E"/>
+          </a:solidFill>
+          <a:ln>
+            <a:noFill/>
+          </a:ln>
+        </p:spPr>
+        <p:style>
+          <a:lnRef idx="2">
+            <a:schemeClr val="accent1">
+              <a:shade val="50000"/>
+            </a:schemeClr>
+          </a:lnRef>
+          <a:fillRef idx="1">
+            <a:schemeClr val="accent1"/>
+          </a:fillRef>
+          <a:effectRef idx="0">
+            <a:schemeClr val="accent1"/>
+          </a:effectRef>
+          <a:fontRef idx="minor">
+            <a:schemeClr val="lt1"/>
+          </a:fontRef>
+        </p:style>
+        <p:txBody>
+          <a:bodyPr rtlCol="0" anchor="ctr"/>
+          <a:lstStyle/>
+          <a:p>
+            <a:pPr algn="ctr"/>
+            <a:endParaRPr lang="en-US"/>
+          </a:p>
+        </p:txBody>
+      </p:sp>
+      <p:sp>
+        <p:nvSpPr>
+          <p:cNvPr id="7" name="Rectangle 6">
+            <a:extLst>
+              <a:ext uri="{FF2B5EF4-FFF2-40B4-BE49-F238E27FC236}">
+                <a16:creationId xmlns:a16="http://schemas.microsoft.com/office/drawing/2014/main" id="{3F22B226-3D3D-0C4D-A38D-EAFD59989359}"/>
+              </a:ext>
+            </a:extLst>
+          </p:cNvPr>
+          <p:cNvSpPr/>
+          <p:nvPr/>
+        </p:nvSpPr>
+        <p:spPr>
+          <a:xfrm>
+            <a:off x="8508467" y="2825903"/>
+            <a:ext cx="2069182" cy="553057"/>
+          </a:xfrm>
+          <a:prstGeom prst="rect">
+            <a:avLst/>
+          </a:prstGeom>
+          <a:solidFill>
+            <a:srgbClr val="335C7E"/>
+          </a:solidFill>
+          <a:ln>
+            <a:noFill/>
+          </a:ln>
+        </p:spPr>
+        <p:style>
+          <a:lnRef idx="2">
+            <a:schemeClr val="accent1">
+              <a:shade val="50000"/>
+            </a:schemeClr>
+          </a:lnRef>
+          <a:fillRef idx="1">
+            <a:schemeClr val="accent1"/>
+          </a:fillRef>
+          <a:effectRef idx="0">
+            <a:schemeClr val="accent1"/>
+          </a:effectRef>
+          <a:fontRef idx="minor">
+            <a:schemeClr val="lt1"/>
+          </a:fontRef>
+        </p:style>
+        <p:txBody>
+          <a:bodyPr rtlCol="0" anchor="ctr"/>
+          <a:lstStyle/>
+          <a:p>
+            <a:pPr algn="ctr"/>
+            <a:endParaRPr lang="en-US"/>
+          </a:p>
+        </p:txBody>
+      </p:sp>
+      <p:sp>
+        <p:nvSpPr>
+          <p:cNvPr id="14" name="L-shape 13">
+            <a:extLst>
+              <a:ext uri="{FF2B5EF4-FFF2-40B4-BE49-F238E27FC236}">
+                <a16:creationId xmlns:a16="http://schemas.microsoft.com/office/drawing/2014/main" id="{485B310F-9058-C34C-857B-7E8BBF30E2DF}"/>
+              </a:ext>
+            </a:extLst>
+          </p:cNvPr>
+          <p:cNvSpPr/>
+          <p:nvPr/>
+        </p:nvSpPr>
+        <p:spPr>
+          <a:xfrm rot="2652370">
+            <a:off x="1243808" y="1642009"/>
+            <a:ext cx="1720800" cy="1720800"/>
+          </a:xfrm>
+          <a:prstGeom prst="corner">
+            <a:avLst>
+              <a:gd name="adj1" fmla="val 23254"/>
+              <a:gd name="adj2" fmla="val 21743"/>
+            </a:avLst>
+          </a:prstGeom>
+          <a:solidFill>
+            <a:srgbClr val="F3F1F4"/>
+          </a:solidFill>
+          <a:ln>
+            <a:noFill/>
+          </a:ln>
+        </p:spPr>
+        <p:style>
+          <a:lnRef idx="2">
+            <a:schemeClr val="accent1">
+              <a:shade val="50000"/>
+            </a:schemeClr>
+          </a:lnRef>
+          <a:fillRef idx="1">
+            <a:schemeClr val="accent1"/>
+          </a:fillRef>
+          <a:effectRef idx="0">
+            <a:schemeClr val="accent1"/>
+          </a:effectRef>
+          <a:fontRef idx="minor">
+            <a:schemeClr val="lt1"/>
+          </a:fontRef>
+        </p:style>
+        <p:txBody>
+          <a:bodyPr rtlCol="0" anchor="ctr"/>
+          <a:lstStyle/>
+          <a:p>
+            <a:pPr algn="ctr"/>
+            <a:endParaRPr lang="en-US"/>
+          </a:p>
+        </p:txBody>
+      </p:sp>
+      <p:sp>
+        <p:nvSpPr>
+          <p:cNvPr id="17" name="Rectangle 16">
+            <a:extLst>
+              <a:ext uri="{FF2B5EF4-FFF2-40B4-BE49-F238E27FC236}">
+                <a16:creationId xmlns:a16="http://schemas.microsoft.com/office/drawing/2014/main" id="{057DA880-815F-7147-B000-379DD7AB3ACF}"/>
+              </a:ext>
+            </a:extLst>
+          </p:cNvPr>
+          <p:cNvSpPr/>
+          <p:nvPr/>
+        </p:nvSpPr>
+        <p:spPr>
+          <a:xfrm>
+            <a:off x="1387822" y="2299483"/>
+            <a:ext cx="2069182" cy="405851"/>
+          </a:xfrm>
+          <a:prstGeom prst="rect">
+            <a:avLst/>
+          </a:prstGeom>
+          <a:solidFill>
+            <a:srgbClr val="F3F1F4"/>
+          </a:solidFill>
+          <a:ln>
+            <a:noFill/>
+          </a:ln>
+        </p:spPr>
+        <p:style>
+          <a:lnRef idx="2">
+            <a:schemeClr val="accent1">
+              <a:shade val="50000"/>
+            </a:schemeClr>
+          </a:lnRef>
+          <a:fillRef idx="1">
+            <a:schemeClr val="accent1"/>
+          </a:fillRef>
+          <a:effectRef idx="0">
+            <a:schemeClr val="accent1"/>
+          </a:effectRef>
+          <a:fontRef idx="minor">
+            <a:schemeClr val="lt1"/>
+          </a:fontRef>
+        </p:style>
+        <p:txBody>
+          <a:bodyPr rtlCol="0" anchor="ctr"/>
+          <a:lstStyle/>
+          <a:p>
+            <a:pPr algn="ctr"/>
+            <a:endParaRPr lang="en-US"/>
+          </a:p>
+        </p:txBody>
+      </p:sp>
+      <p:sp>
+        <p:nvSpPr>
+          <p:cNvPr id="5" name="Rectangle 4">
+            <a:extLst>
+              <a:ext uri="{FF2B5EF4-FFF2-40B4-BE49-F238E27FC236}">
+                <a16:creationId xmlns:a16="http://schemas.microsoft.com/office/drawing/2014/main" id="{9A427F68-04E0-7C40-B84B-D8B8ADB897CF}"/>
+              </a:ext>
+            </a:extLst>
+          </p:cNvPr>
+          <p:cNvSpPr/>
+          <p:nvPr/>
+        </p:nvSpPr>
+        <p:spPr>
+          <a:xfrm>
+            <a:off x="154684" y="438303"/>
+            <a:ext cx="5756259" cy="4580011"/>
+          </a:xfrm>
+          <a:prstGeom prst="rect">
+            <a:avLst/>
+          </a:prstGeom>
+          <a:noFill/>
+          <a:ln>
+            <a:noFill/>
+          </a:ln>
+        </p:spPr>
+        <p:style>
+          <a:lnRef idx="2">
+            <a:schemeClr val="accent1">
+              <a:shade val="50000"/>
+            </a:schemeClr>
+          </a:lnRef>
+          <a:fillRef idx="1">
+            <a:schemeClr val="accent1"/>
+          </a:fillRef>
+          <a:effectRef idx="0">
+            <a:schemeClr val="accent1"/>
+          </a:effectRef>
+          <a:fontRef idx="minor">
+            <a:schemeClr val="lt1"/>
+          </a:fontRef>
+        </p:style>
+        <p:txBody>
+          <a:bodyPr rtlCol="0" anchor="ctr"/>
+          <a:lstStyle/>
+          <a:p>
+            <a:pPr algn="ctr"/>
+            <a:endParaRPr lang="en-US"/>
+          </a:p>
+        </p:txBody>
+      </p:sp>
+    </p:spTree>
+    <p:extLst>
+      <p:ext uri="{BB962C8B-B14F-4D97-AF65-F5344CB8AC3E}">
+        <p14:creationId xmlns:p14="http://schemas.microsoft.com/office/powerpoint/2010/main" val="4276385129"/>
+      </p:ext>
+    </p:extLst>
+  </p:cSld>
+  <p:clrMapOvr>
+    <a:masterClrMapping/>
+  </p:clrMapOvr>
+</p:sld>
+</file>
+
+<file path=ppt/slides/slide7.xml><?xml version="1.0" encoding="utf-8"?>
+<p:sld xmlns:a="http://schemas.openxmlformats.org/drawingml/2006/main" xmlns:r="http://schemas.openxmlformats.org/officeDocument/2006/relationships" xmlns:p="http://schemas.openxmlformats.org/presentationml/2006/main">
+  <p:cSld>
+    <p:spTree>
+      <p:nvGrpSpPr>
+        <p:cNvPr id="1" name=""/>
+        <p:cNvGrpSpPr/>
+        <p:nvPr/>
+      </p:nvGrpSpPr>
+      <p:grpSpPr>
+        <a:xfrm>
+          <a:off x="0" y="0"/>
+          <a:ext cx="0" cy="0"/>
+          <a:chOff x="0" y="0"/>
+          <a:chExt cx="0" cy="0"/>
+        </a:xfrm>
+      </p:grpSpPr>
+      <p:sp>
+        <p:nvSpPr>
+          <p:cNvPr id="5" name="Rectangle 4">
+            <a:extLst>
+              <a:ext uri="{FF2B5EF4-FFF2-40B4-BE49-F238E27FC236}">
+                <a16:creationId xmlns:a16="http://schemas.microsoft.com/office/drawing/2014/main" id="{9A427F68-04E0-7C40-B84B-D8B8ADB897CF}"/>
+              </a:ext>
+            </a:extLst>
+          </p:cNvPr>
+          <p:cNvSpPr/>
+          <p:nvPr/>
+        </p:nvSpPr>
+        <p:spPr>
+          <a:xfrm>
+            <a:off x="154684" y="438303"/>
+            <a:ext cx="5756259" cy="4580011"/>
+          </a:xfrm>
+          <a:prstGeom prst="rect">
+            <a:avLst/>
+          </a:prstGeom>
+          <a:noFill/>
+          <a:ln>
+            <a:noFill/>
+          </a:ln>
+        </p:spPr>
+        <p:style>
+          <a:lnRef idx="2">
+            <a:schemeClr val="accent1">
+              <a:shade val="50000"/>
+            </a:schemeClr>
+          </a:lnRef>
+          <a:fillRef idx="1">
+            <a:schemeClr val="accent1"/>
+          </a:fillRef>
+          <a:effectRef idx="0">
+            <a:schemeClr val="accent1"/>
+          </a:effectRef>
+          <a:fontRef idx="minor">
+            <a:schemeClr val="lt1"/>
+          </a:fontRef>
+        </p:style>
+        <p:txBody>
+          <a:bodyPr rtlCol="0" anchor="ctr"/>
+          <a:lstStyle/>
+          <a:p>
+            <a:pPr algn="ctr"/>
+            <a:endParaRPr lang="en-US"/>
+          </a:p>
+        </p:txBody>
+      </p:sp>
+      <p:sp>
+        <p:nvSpPr>
+          <p:cNvPr id="8" name="Rectangle 7">
+            <a:extLst>
+              <a:ext uri="{FF2B5EF4-FFF2-40B4-BE49-F238E27FC236}">
+                <a16:creationId xmlns:a16="http://schemas.microsoft.com/office/drawing/2014/main" id="{A1685247-8415-414F-B3CE-089251D6C360}"/>
+              </a:ext>
+            </a:extLst>
+          </p:cNvPr>
+          <p:cNvSpPr/>
+          <p:nvPr/>
+        </p:nvSpPr>
+        <p:spPr>
+          <a:xfrm>
+            <a:off x="12700" y="3000375"/>
+            <a:ext cx="12166600" cy="148514"/>
+          </a:xfrm>
+          <a:prstGeom prst="rect">
+            <a:avLst/>
+          </a:prstGeom>
+          <a:solidFill>
+            <a:srgbClr val="339889"/>
+          </a:solidFill>
+          <a:ln>
+            <a:noFill/>
+          </a:ln>
+        </p:spPr>
+        <p:style>
+          <a:lnRef idx="2">
+            <a:schemeClr val="accent1">
+              <a:shade val="50000"/>
+            </a:schemeClr>
+          </a:lnRef>
+          <a:fillRef idx="1">
+            <a:schemeClr val="accent1"/>
+          </a:fillRef>
+          <a:effectRef idx="0">
+            <a:schemeClr val="accent1"/>
+          </a:effectRef>
+          <a:fontRef idx="minor">
+            <a:schemeClr val="lt1"/>
+          </a:fontRef>
+        </p:style>
+        <p:txBody>
+          <a:bodyPr rtlCol="0" anchor="ctr"/>
+          <a:lstStyle/>
+          <a:p>
+            <a:pPr algn="ctr"/>
+            <a:endParaRPr lang="en-US"/>
+          </a:p>
+        </p:txBody>
+      </p:sp>
+    </p:spTree>
+    <p:extLst>
+      <p:ext uri="{BB962C8B-B14F-4D97-AF65-F5344CB8AC3E}">
+        <p14:creationId xmlns:p14="http://schemas.microsoft.com/office/powerpoint/2010/main" val="4143478526"/>
+      </p:ext>
+    </p:extLst>
+  </p:cSld>
+  <p:clrMapOvr>
+    <a:masterClrMapping/>
+  </p:clrMapOvr>
+</p:sld>
+</file>
+
 <file path=ppt/theme/theme1.xml><?xml version="1.0" encoding="utf-8"?>
 <a:theme xmlns:a="http://schemas.openxmlformats.org/drawingml/2006/main" name="Office Theme">
   <a:themeElements>

</xml_diff>